<commit_message>
Update slide 5c: side-by-side training/eval tables
Training (left): atomic (65 tasks, 6,500 eps) + composite (252, 25,200) +
MimicGen (60, 600k) = ~631,700 total episodes.
Evaluation (right): 3-split breakdown (atomic-seen 18, composite-seen 16,
composite-unseen 16) = 25,000 total demos.
</commit_message>
<xml_diff>
--- a/robocasa_slides.pptx
+++ b/robocasa_slides.pptx
@@ -22504,7 +22504,7 @@
         <p:spPr>
           <a:xfrm>
             <a:off x="457200" y="960120"/>
-            <a:ext cx="11247120" cy="292608"/>
+            <a:ext cx="5577840" cy="292608"/>
           </a:xfrm>
           <a:prstGeom prst="rect">
             <a:avLst/>
@@ -22540,7 +22540,7 @@
         </p:nvGraphicFramePr>
         <p:xfrm>
           <a:off x="457200" y="1307592"/>
-          <a:ext cx="11247120" cy="1417320"/>
+          <a:ext cx="5577840" cy="1965960"/>
         </p:xfrm>
         <a:graphic>
           <a:graphicData uri="http://schemas.openxmlformats.org/drawingml/2006/table">
@@ -22549,14 +22549,12 @@
                 <a:tableStyleId>{5C22544A-7EE6-4342-B048-85BDC9FD1C3A}</a:tableStyleId>
               </a:tblPr>
               <a:tblGrid>
-                <a:gridCol w="2286000"/>
+                <a:gridCol w="2331720"/>
                 <a:gridCol w="914400"/>
-                <a:gridCol w="914400"/>
-                <a:gridCol w="1371600"/>
-                <a:gridCol w="1554480"/>
-                <a:gridCol w="4206240"/>
+                <a:gridCol w="1188720"/>
+                <a:gridCol w="1143000"/>
               </a:tblGrid>
-              <a:tr h="354330">
+              <a:tr h="327660">
                 <a:tc>
                   <a:txBody>
                     <a:bodyPr/>
@@ -22593,7 +22591,7 @@
                           </a:solidFill>
                           <a:latin typeface="Calibri"/>
                         </a:rPr>
-                        <a:t>Split</a:t>
+                        <a:t>Tasks</a:t>
                       </a:r>
                     </a:p>
                   </a:txBody>
@@ -22616,7 +22614,7 @@
                           </a:solidFill>
                           <a:latin typeface="Calibri"/>
                         </a:rPr>
-                        <a:t># Tasks</a:t>
+                        <a:t>Episodes / Task</a:t>
                       </a:r>
                     </a:p>
                   </a:txBody>
@@ -22639,7 +22637,7 @@
                           </a:solidFill>
                           <a:latin typeface="Calibri"/>
                         </a:rPr>
-                        <a:t>Demos / Task</a:t>
+                        <a:t>Total Episodes</a:t>
                       </a:r>
                     </a:p>
                   </a:txBody>
@@ -22649,54 +22647,8 @@
                     </a:solidFill>
                   </a:tcPr>
                 </a:tc>
-                <a:tc>
-                  <a:txBody>
-                    <a:bodyPr/>
-                    <a:lstStyle/>
-                    <a:p>
-                      <a:pPr algn="l"/>
-                      <a:r>
-                        <a:rPr sz="1200" b="1">
-                          <a:solidFill>
-                            <a:srgbClr val="1F4E79"/>
-                          </a:solidFill>
-                          <a:latin typeface="Calibri"/>
-                        </a:rPr>
-                        <a:t>Total Demos</a:t>
-                      </a:r>
-                    </a:p>
-                  </a:txBody>
-                  <a:tcPr>
-                    <a:solidFill>
-                      <a:srgbClr val="D6E4F0"/>
-                    </a:solidFill>
-                  </a:tcPr>
-                </a:tc>
-                <a:tc>
-                  <a:txBody>
-                    <a:bodyPr/>
-                    <a:lstStyle/>
-                    <a:p>
-                      <a:pPr algn="l"/>
-                      <a:r>
-                        <a:rPr sz="1200" b="1">
-                          <a:solidFill>
-                            <a:srgbClr val="1F4E79"/>
-                          </a:solidFill>
-                          <a:latin typeface="Calibri"/>
-                        </a:rPr>
-                        <a:t>Total Hours</a:t>
-                      </a:r>
-                    </a:p>
-                  </a:txBody>
-                  <a:tcPr>
-                    <a:solidFill>
-                      <a:srgbClr val="D6E4F0"/>
-                    </a:solidFill>
-                  </a:tcPr>
-                </a:tc>
               </a:tr>
-              <a:tr h="354330">
+              <a:tr h="327660">
                 <a:tc>
                   <a:txBody>
                     <a:bodyPr/>
@@ -22710,7 +22662,7 @@
                           </a:solidFill>
                           <a:latin typeface="Calibri"/>
                         </a:rPr>
-                        <a:t>Human teleoperation</a:t>
+                        <a:t>Human demos — atomic</a:t>
                       </a:r>
                     </a:p>
                   </a:txBody>
@@ -22731,7 +22683,7 @@
                           </a:solidFill>
                           <a:latin typeface="Calibri"/>
                         </a:rPr>
-                        <a:t>Pretrain</a:t>
+                        <a:t>65</a:t>
                       </a:r>
                     </a:p>
                   </a:txBody>
@@ -22752,7 +22704,7 @@
                           </a:solidFill>
                           <a:latin typeface="Calibri"/>
                         </a:rPr>
-                        <a:t>300</a:t>
+                        <a:t>~100</a:t>
                       </a:r>
                     </a:p>
                   </a:txBody>
@@ -22773,7 +22725,7 @@
                           </a:solidFill>
                           <a:latin typeface="Calibri"/>
                         </a:rPr>
-                        <a:t>~100</a:t>
+                        <a:t>6,500</a:t>
                       </a:r>
                     </a:p>
                   </a:txBody>
@@ -22781,6 +22733,8 @@
                     <a:noFill/>
                   </a:tcPr>
                 </a:tc>
+              </a:tr>
+              <a:tr h="327660">
                 <a:tc>
                   <a:txBody>
                     <a:bodyPr/>
@@ -22794,51 +22748,7 @@
                           </a:solidFill>
                           <a:latin typeface="Calibri"/>
                         </a:rPr>
-                        <a:t>~30,000</a:t>
-                      </a:r>
-                    </a:p>
-                  </a:txBody>
-                  <a:tcPr>
-                    <a:noFill/>
-                  </a:tcPr>
-                </a:tc>
-                <a:tc>
-                  <a:txBody>
-                    <a:bodyPr/>
-                    <a:lstStyle/>
-                    <a:p>
-                      <a:pPr algn="l"/>
-                      <a:r>
-                        <a:rPr sz="1100" b="0">
-                          <a:solidFill>
-                            <a:srgbClr val="262626"/>
-                          </a:solidFill>
-                          <a:latin typeface="Calibri"/>
-                        </a:rPr>
-                        <a:t>482 hrs</a:t>
-                      </a:r>
-                    </a:p>
-                  </a:txBody>
-                  <a:tcPr>
-                    <a:noFill/>
-                  </a:tcPr>
-                </a:tc>
-              </a:tr>
-              <a:tr h="354330">
-                <a:tc>
-                  <a:txBody>
-                    <a:bodyPr/>
-                    <a:lstStyle/>
-                    <a:p>
-                      <a:pPr algn="l"/>
-                      <a:r>
-                        <a:rPr sz="1100" b="0">
-                          <a:solidFill>
-                            <a:srgbClr val="262626"/>
-                          </a:solidFill>
-                          <a:latin typeface="Calibri"/>
-                        </a:rPr>
-                        <a:t>MimicGen (synthetic)</a:t>
+                        <a:t>Human demos — composite</a:t>
                       </a:r>
                     </a:p>
                   </a:txBody>
@@ -22861,7 +22771,7 @@
                           </a:solidFill>
                           <a:latin typeface="Calibri"/>
                         </a:rPr>
-                        <a:t>Pretrain</a:t>
+                        <a:t>252</a:t>
                       </a:r>
                     </a:p>
                   </a:txBody>
@@ -22884,7 +22794,7 @@
                           </a:solidFill>
                           <a:latin typeface="Calibri"/>
                         </a:rPr>
-                        <a:t>60</a:t>
+                        <a:t>~100</a:t>
                       </a:r>
                     </a:p>
                   </a:txBody>
@@ -22907,7 +22817,7 @@
                           </a:solidFill>
                           <a:latin typeface="Calibri"/>
                         </a:rPr>
-                        <a:t>~10,000</a:t>
+                        <a:t>25,200</a:t>
                       </a:r>
                     </a:p>
                   </a:txBody>
@@ -22917,6 +22827,50 @@
                     </a:solidFill>
                   </a:tcPr>
                 </a:tc>
+              </a:tr>
+              <a:tr h="327660">
+                <a:tc>
+                  <a:txBody>
+                    <a:bodyPr/>
+                    <a:lstStyle/>
+                    <a:p>
+                      <a:pPr algn="l"/>
+                      <a:r>
+                        <a:rPr sz="1100" b="0">
+                          <a:solidFill>
+                            <a:srgbClr val="595959"/>
+                          </a:solidFill>
+                          <a:latin typeface="Calibri"/>
+                        </a:rPr>
+                        <a:t>Human subtotal</a:t>
+                      </a:r>
+                    </a:p>
+                  </a:txBody>
+                  <a:tcPr>
+                    <a:noFill/>
+                  </a:tcPr>
+                </a:tc>
+                <a:tc>
+                  <a:txBody>
+                    <a:bodyPr/>
+                    <a:lstStyle/>
+                    <a:p>
+                      <a:pPr algn="l"/>
+                      <a:r>
+                        <a:rPr sz="1100" b="0">
+                          <a:solidFill>
+                            <a:srgbClr val="595959"/>
+                          </a:solidFill>
+                          <a:latin typeface="Calibri"/>
+                        </a:rPr>
+                        <a:t>317</a:t>
+                      </a:r>
+                    </a:p>
+                  </a:txBody>
+                  <a:tcPr>
+                    <a:noFill/>
+                  </a:tcPr>
+                </a:tc>
                 <a:tc>
                   <a:txBody>
                     <a:bodyPr/>
@@ -22930,7 +22884,51 @@
                           </a:solidFill>
                           <a:latin typeface="Calibri"/>
                         </a:rPr>
-                        <a:t>~600,000</a:t>
+                        <a:t>—</a:t>
+                      </a:r>
+                    </a:p>
+                  </a:txBody>
+                  <a:tcPr>
+                    <a:noFill/>
+                  </a:tcPr>
+                </a:tc>
+                <a:tc>
+                  <a:txBody>
+                    <a:bodyPr/>
+                    <a:lstStyle/>
+                    <a:p>
+                      <a:pPr algn="l"/>
+                      <a:r>
+                        <a:rPr sz="1100" b="0">
+                          <a:solidFill>
+                            <a:srgbClr val="595959"/>
+                          </a:solidFill>
+                          <a:latin typeface="Calibri"/>
+                        </a:rPr>
+                        <a:t>~31,700</a:t>
+                      </a:r>
+                    </a:p>
+                  </a:txBody>
+                  <a:tcPr>
+                    <a:noFill/>
+                  </a:tcPr>
+                </a:tc>
+              </a:tr>
+              <a:tr h="327660">
+                <a:tc>
+                  <a:txBody>
+                    <a:bodyPr/>
+                    <a:lstStyle/>
+                    <a:p>
+                      <a:pPr algn="l"/>
+                      <a:r>
+                        <a:rPr sz="1100" b="0">
+                          <a:solidFill>
+                            <a:srgbClr val="262626"/>
+                          </a:solidFill>
+                          <a:latin typeface="Calibri"/>
+                        </a:rPr>
+                        <a:t>MimicGen (synthetic)</a:t>
                       </a:r>
                     </a:p>
                   </a:txBody>
@@ -22953,7 +22951,7 @@
                           </a:solidFill>
                           <a:latin typeface="Calibri"/>
                         </a:rPr>
-                        <a:t>1,615 hrs</a:t>
+                        <a:t>60 atomic</a:t>
                       </a:r>
                     </a:p>
                   </a:txBody>
@@ -22963,8 +22961,54 @@
                     </a:solidFill>
                   </a:tcPr>
                 </a:tc>
+                <a:tc>
+                  <a:txBody>
+                    <a:bodyPr/>
+                    <a:lstStyle/>
+                    <a:p>
+                      <a:pPr algn="l"/>
+                      <a:r>
+                        <a:rPr sz="1100" b="0">
+                          <a:solidFill>
+                            <a:srgbClr val="262626"/>
+                          </a:solidFill>
+                          <a:latin typeface="Calibri"/>
+                        </a:rPr>
+                        <a:t>~10,000</a:t>
+                      </a:r>
+                    </a:p>
+                  </a:txBody>
+                  <a:tcPr>
+                    <a:solidFill>
+                      <a:srgbClr val="F2F2F2"/>
+                    </a:solidFill>
+                  </a:tcPr>
+                </a:tc>
+                <a:tc>
+                  <a:txBody>
+                    <a:bodyPr/>
+                    <a:lstStyle/>
+                    <a:p>
+                      <a:pPr algn="l"/>
+                      <a:r>
+                        <a:rPr sz="1100" b="0">
+                          <a:solidFill>
+                            <a:srgbClr val="262626"/>
+                          </a:solidFill>
+                          <a:latin typeface="Calibri"/>
+                        </a:rPr>
+                        <a:t>~600,000</a:t>
+                      </a:r>
+                    </a:p>
+                  </a:txBody>
+                  <a:tcPr>
+                    <a:solidFill>
+                      <a:srgbClr val="F2F2F2"/>
+                    </a:solidFill>
+                  </a:tcPr>
+                </a:tc>
               </a:tr>
-              <a:tr h="354330">
+              <a:tr h="327660">
                 <a:tc>
                   <a:txBody>
                     <a:bodyPr/>
@@ -22978,7 +23022,7 @@
                           </a:solidFill>
                           <a:latin typeface="Calibri"/>
                         </a:rPr>
-                        <a:t>Total</a:t>
+                        <a:t>Grand total</a:t>
                       </a:r>
                     </a:p>
                   </a:txBody>
@@ -23016,74 +23060,32 @@
                       <a:r>
                         <a:rPr sz="1100" b="0">
                           <a:solidFill>
+                            <a:srgbClr val="262626"/>
+                          </a:solidFill>
+                          <a:latin typeface="Calibri"/>
+                        </a:rPr>
+                        <a:t>—</a:t>
+                      </a:r>
+                    </a:p>
+                  </a:txBody>
+                  <a:tcPr>
+                    <a:noFill/>
+                  </a:tcPr>
+                </a:tc>
+                <a:tc>
+                  <a:txBody>
+                    <a:bodyPr/>
+                    <a:lstStyle/>
+                    <a:p>
+                      <a:pPr algn="l"/>
+                      <a:r>
+                        <a:rPr sz="1100" b="0">
+                          <a:solidFill>
                             <a:srgbClr val="1F4E79"/>
                           </a:solidFill>
                           <a:latin typeface="Calibri"/>
                         </a:rPr>
-                        <a:t>360</a:t>
-                      </a:r>
-                    </a:p>
-                  </a:txBody>
-                  <a:tcPr>
-                    <a:noFill/>
-                  </a:tcPr>
-                </a:tc>
-                <a:tc>
-                  <a:txBody>
-                    <a:bodyPr/>
-                    <a:lstStyle/>
-                    <a:p>
-                      <a:pPr algn="l"/>
-                      <a:r>
-                        <a:rPr sz="1100" b="0">
-                          <a:solidFill>
-                            <a:srgbClr val="262626"/>
-                          </a:solidFill>
-                          <a:latin typeface="Calibri"/>
-                        </a:rPr>
-                        <a:t>—</a:t>
-                      </a:r>
-                    </a:p>
-                  </a:txBody>
-                  <a:tcPr>
-                    <a:noFill/>
-                  </a:tcPr>
-                </a:tc>
-                <a:tc>
-                  <a:txBody>
-                    <a:bodyPr/>
-                    <a:lstStyle/>
-                    <a:p>
-                      <a:pPr algn="l"/>
-                      <a:r>
-                        <a:rPr sz="1100" b="0">
-                          <a:solidFill>
-                            <a:srgbClr val="1F4E79"/>
-                          </a:solidFill>
-                          <a:latin typeface="Calibri"/>
-                        </a:rPr>
-                        <a:t>~630,000</a:t>
-                      </a:r>
-                    </a:p>
-                  </a:txBody>
-                  <a:tcPr>
-                    <a:noFill/>
-                  </a:tcPr>
-                </a:tc>
-                <a:tc>
-                  <a:txBody>
-                    <a:bodyPr/>
-                    <a:lstStyle/>
-                    <a:p>
-                      <a:pPr algn="l"/>
-                      <a:r>
-                        <a:rPr sz="1100" b="0">
-                          <a:solidFill>
-                            <a:srgbClr val="1F4E79"/>
-                          </a:solidFill>
-                          <a:latin typeface="Calibri"/>
-                        </a:rPr>
-                        <a:t>~2,097 hrs</a:t>
+                        <a:t>~631,700</a:t>
                       </a:r>
                     </a:p>
                   </a:txBody>
@@ -23104,8 +23106,8 @@
         </p:nvSpPr>
         <p:spPr>
           <a:xfrm>
-            <a:off x="457200" y="2880360"/>
-            <a:ext cx="11247120" cy="292608"/>
+            <a:off x="6217920" y="960120"/>
+            <a:ext cx="5486400" cy="292608"/>
           </a:xfrm>
           <a:prstGeom prst="rect">
             <a:avLst/>
@@ -23126,7 +23128,7 @@
                 </a:solidFill>
                 <a:latin typeface="Calibri"/>
               </a:rPr>
-              <a:t>Evaluation Data  (Target Split — RoboCasa365, ICLR 2026)</a:t>
+              <a:t>Evaluation Data  (Target Split — RoboCasa365)</a:t>
             </a:r>
           </a:p>
         </p:txBody>
@@ -23140,8 +23142,8 @@
           <p:nvPr/>
         </p:nvGraphicFramePr>
         <p:xfrm>
-          <a:off x="457200" y="3227832"/>
-          <a:ext cx="11247120" cy="1691640"/>
+          <a:off x="6217920" y="1307592"/>
+          <a:ext cx="5486400" cy="1691640"/>
         </p:xfrm>
         <a:graphic>
           <a:graphicData uri="http://schemas.openxmlformats.org/drawingml/2006/table">
@@ -23150,12 +23152,10 @@
                 <a:tableStyleId>{5C22544A-7EE6-4342-B048-85BDC9FD1C3A}</a:tableStyleId>
               </a:tblPr>
               <a:tblGrid>
-                <a:gridCol w="2286000"/>
-                <a:gridCol w="914400"/>
-                <a:gridCol w="914400"/>
-                <a:gridCol w="1828800"/>
-                <a:gridCol w="1371600"/>
-                <a:gridCol w="3931920"/>
+                <a:gridCol w="2103120"/>
+                <a:gridCol w="731520"/>
+                <a:gridCol w="1188720"/>
+                <a:gridCol w="1463040"/>
               </a:tblGrid>
               <a:tr h="338328">
                 <a:tc>
@@ -23171,7 +23171,7 @@
                           </a:solidFill>
                           <a:latin typeface="Calibri"/>
                         </a:rPr>
-                        <a:t>Source</a:t>
+                        <a:t>Subset</a:t>
                       </a:r>
                     </a:p>
                   </a:txBody>
@@ -23194,7 +23194,7 @@
                           </a:solidFill>
                           <a:latin typeface="Calibri"/>
                         </a:rPr>
-                        <a:t>Split</a:t>
+                        <a:t>Tasks</a:t>
                       </a:r>
                     </a:p>
                   </a:txBody>
@@ -23217,7 +23217,7 @@
                           </a:solidFill>
                           <a:latin typeface="Calibri"/>
                         </a:rPr>
-                        <a:t># Tasks</a:t>
+                        <a:t>Demos / Task</a:t>
                       </a:r>
                     </a:p>
                   </a:txBody>
@@ -23240,7 +23240,7 @@
                           </a:solidFill>
                           <a:latin typeface="Calibri"/>
                         </a:rPr>
-                        <a:t>Subset</a:t>
+                        <a:t>Total Demos</a:t>
                       </a:r>
                     </a:p>
                   </a:txBody>
@@ -23250,52 +23250,6 @@
                     </a:solidFill>
                   </a:tcPr>
                 </a:tc>
-                <a:tc>
-                  <a:txBody>
-                    <a:bodyPr/>
-                    <a:lstStyle/>
-                    <a:p>
-                      <a:pPr algn="l"/>
-                      <a:r>
-                        <a:rPr sz="1200" b="1">
-                          <a:solidFill>
-                            <a:srgbClr val="1F4E79"/>
-                          </a:solidFill>
-                          <a:latin typeface="Calibri"/>
-                        </a:rPr>
-                        <a:t>Demos / Task</a:t>
-                      </a:r>
-                    </a:p>
-                  </a:txBody>
-                  <a:tcPr>
-                    <a:solidFill>
-                      <a:srgbClr val="D6E4F0"/>
-                    </a:solidFill>
-                  </a:tcPr>
-                </a:tc>
-                <a:tc>
-                  <a:txBody>
-                    <a:bodyPr/>
-                    <a:lstStyle/>
-                    <a:p>
-                      <a:pPr algn="l"/>
-                      <a:r>
-                        <a:rPr sz="1200" b="1">
-                          <a:solidFill>
-                            <a:srgbClr val="1F4E79"/>
-                          </a:solidFill>
-                          <a:latin typeface="Calibri"/>
-                        </a:rPr>
-                        <a:t>Total Demos</a:t>
-                      </a:r>
-                    </a:p>
-                  </a:txBody>
-                  <a:tcPr>
-                    <a:solidFill>
-                      <a:srgbClr val="D6E4F0"/>
-                    </a:solidFill>
-                  </a:tcPr>
-                </a:tc>
               </a:tr>
               <a:tr h="338328">
                 <a:tc>
@@ -23311,7 +23265,7 @@
                           </a:solidFill>
                           <a:latin typeface="Calibri"/>
                         </a:rPr>
-                        <a:t>Human teleoperation</a:t>
+                        <a:t>Atomic-seen</a:t>
                       </a:r>
                     </a:p>
                   </a:txBody>
@@ -23332,49 +23286,7 @@
                           </a:solidFill>
                           <a:latin typeface="Calibri"/>
                         </a:rPr>
-                        <a:t>Target</a:t>
-                      </a:r>
-                    </a:p>
-                  </a:txBody>
-                  <a:tcPr>
-                    <a:noFill/>
-                  </a:tcPr>
-                </a:tc>
-                <a:tc>
-                  <a:txBody>
-                    <a:bodyPr/>
-                    <a:lstStyle/>
-                    <a:p>
-                      <a:pPr algn="l"/>
-                      <a:r>
-                        <a:rPr sz="1100" b="0">
-                          <a:solidFill>
-                            <a:srgbClr val="262626"/>
-                          </a:solidFill>
-                          <a:latin typeface="Calibri"/>
-                        </a:rPr>
                         <a:t>18</a:t>
-                      </a:r>
-                    </a:p>
-                  </a:txBody>
-                  <a:tcPr>
-                    <a:noFill/>
-                  </a:tcPr>
-                </a:tc>
-                <a:tc>
-                  <a:txBody>
-                    <a:bodyPr/>
-                    <a:lstStyle/>
-                    <a:p>
-                      <a:pPr algn="l"/>
-                      <a:r>
-                        <a:rPr sz="1100" b="0">
-                          <a:solidFill>
-                            <a:srgbClr val="262626"/>
-                          </a:solidFill>
-                          <a:latin typeface="Calibri"/>
-                        </a:rPr>
-                        <a:t>Atomic-seen</a:t>
                       </a:r>
                     </a:p>
                   </a:txBody>
@@ -23439,7 +23351,7 @@
                           </a:solidFill>
                           <a:latin typeface="Calibri"/>
                         </a:rPr>
-                        <a:t>Human teleoperation</a:t>
+                        <a:t>Composite-seen</a:t>
                       </a:r>
                     </a:p>
                   </a:txBody>
@@ -23462,7 +23374,7 @@
                           </a:solidFill>
                           <a:latin typeface="Calibri"/>
                         </a:rPr>
-                        <a:t>Target</a:t>
+                        <a:t>16</a:t>
                       </a:r>
                     </a:p>
                   </a:txBody>
@@ -23485,7 +23397,7 @@
                           </a:solidFill>
                           <a:latin typeface="Calibri"/>
                         </a:rPr>
-                        <a:t>16</a:t>
+                        <a:t>~500</a:t>
                       </a:r>
                     </a:p>
                   </a:txBody>
@@ -23508,7 +23420,7 @@
                           </a:solidFill>
                           <a:latin typeface="Calibri"/>
                         </a:rPr>
-                        <a:t>Composite-seen</a:t>
+                        <a:t>~8,000</a:t>
                       </a:r>
                     </a:p>
                   </a:txBody>
@@ -23518,6 +23430,8 @@
                     </a:solidFill>
                   </a:tcPr>
                 </a:tc>
+              </a:tr>
+              <a:tr h="338328">
                 <a:tc>
                   <a:txBody>
                     <a:bodyPr/>
@@ -23531,7 +23445,93 @@
                           </a:solidFill>
                           <a:latin typeface="Calibri"/>
                         </a:rPr>
+                        <a:t>Composite-unseen</a:t>
+                      </a:r>
+                    </a:p>
+                  </a:txBody>
+                  <a:tcPr>
+                    <a:noFill/>
+                  </a:tcPr>
+                </a:tc>
+                <a:tc>
+                  <a:txBody>
+                    <a:bodyPr/>
+                    <a:lstStyle/>
+                    <a:p>
+                      <a:pPr algn="l"/>
+                      <a:r>
+                        <a:rPr sz="1100" b="0">
+                          <a:solidFill>
+                            <a:srgbClr val="262626"/>
+                          </a:solidFill>
+                          <a:latin typeface="Calibri"/>
+                        </a:rPr>
+                        <a:t>16</a:t>
+                      </a:r>
+                    </a:p>
+                  </a:txBody>
+                  <a:tcPr>
+                    <a:noFill/>
+                  </a:tcPr>
+                </a:tc>
+                <a:tc>
+                  <a:txBody>
+                    <a:bodyPr/>
+                    <a:lstStyle/>
+                    <a:p>
+                      <a:pPr algn="l"/>
+                      <a:r>
+                        <a:rPr sz="1100" b="0">
+                          <a:solidFill>
+                            <a:srgbClr val="262626"/>
+                          </a:solidFill>
+                          <a:latin typeface="Calibri"/>
+                        </a:rPr>
                         <a:t>~500</a:t>
+                      </a:r>
+                    </a:p>
+                  </a:txBody>
+                  <a:tcPr>
+                    <a:noFill/>
+                  </a:tcPr>
+                </a:tc>
+                <a:tc>
+                  <a:txBody>
+                    <a:bodyPr/>
+                    <a:lstStyle/>
+                    <a:p>
+                      <a:pPr algn="l"/>
+                      <a:r>
+                        <a:rPr sz="1100" b="0">
+                          <a:solidFill>
+                            <a:srgbClr val="262626"/>
+                          </a:solidFill>
+                          <a:latin typeface="Calibri"/>
+                        </a:rPr>
+                        <a:t>~8,000</a:t>
+                      </a:r>
+                    </a:p>
+                  </a:txBody>
+                  <a:tcPr>
+                    <a:noFill/>
+                  </a:tcPr>
+                </a:tc>
+              </a:tr>
+              <a:tr h="338328">
+                <a:tc>
+                  <a:txBody>
+                    <a:bodyPr/>
+                    <a:lstStyle/>
+                    <a:p>
+                      <a:pPr algn="l"/>
+                      <a:r>
+                        <a:rPr sz="1100" b="0">
+                          <a:solidFill>
+                            <a:srgbClr val="1F4E79"/>
+                          </a:solidFill>
+                          <a:latin typeface="Calibri"/>
+                        </a:rPr>
+                        <a:t>Total</a:t>
                       </a:r>
                     </a:p>
                   </a:txBody>
@@ -23550,233 +23550,11 @@
                       <a:r>
                         <a:rPr sz="1100" b="0">
                           <a:solidFill>
-                            <a:srgbClr val="262626"/>
-                          </a:solidFill>
-                          <a:latin typeface="Calibri"/>
-                        </a:rPr>
-                        <a:t>~8,000</a:t>
-                      </a:r>
-                    </a:p>
-                  </a:txBody>
-                  <a:tcPr>
-                    <a:solidFill>
-                      <a:srgbClr val="F2F2F2"/>
-                    </a:solidFill>
-                  </a:tcPr>
-                </a:tc>
-              </a:tr>
-              <a:tr h="338328">
-                <a:tc>
-                  <a:txBody>
-                    <a:bodyPr/>
-                    <a:lstStyle/>
-                    <a:p>
-                      <a:pPr algn="l"/>
-                      <a:r>
-                        <a:rPr sz="1100" b="0">
-                          <a:solidFill>
-                            <a:srgbClr val="262626"/>
-                          </a:solidFill>
-                          <a:latin typeface="Calibri"/>
-                        </a:rPr>
-                        <a:t>Human teleoperation</a:t>
-                      </a:r>
-                    </a:p>
-                  </a:txBody>
-                  <a:tcPr>
-                    <a:noFill/>
-                  </a:tcPr>
-                </a:tc>
-                <a:tc>
-                  <a:txBody>
-                    <a:bodyPr/>
-                    <a:lstStyle/>
-                    <a:p>
-                      <a:pPr algn="l"/>
-                      <a:r>
-                        <a:rPr sz="1100" b="0">
-                          <a:solidFill>
-                            <a:srgbClr val="262626"/>
-                          </a:solidFill>
-                          <a:latin typeface="Calibri"/>
-                        </a:rPr>
-                        <a:t>Target</a:t>
-                      </a:r>
-                    </a:p>
-                  </a:txBody>
-                  <a:tcPr>
-                    <a:noFill/>
-                  </a:tcPr>
-                </a:tc>
-                <a:tc>
-                  <a:txBody>
-                    <a:bodyPr/>
-                    <a:lstStyle/>
-                    <a:p>
-                      <a:pPr algn="l"/>
-                      <a:r>
-                        <a:rPr sz="1100" b="0">
-                          <a:solidFill>
-                            <a:srgbClr val="262626"/>
-                          </a:solidFill>
-                          <a:latin typeface="Calibri"/>
-                        </a:rPr>
-                        <a:t>16</a:t>
-                      </a:r>
-                    </a:p>
-                  </a:txBody>
-                  <a:tcPr>
-                    <a:noFill/>
-                  </a:tcPr>
-                </a:tc>
-                <a:tc>
-                  <a:txBody>
-                    <a:bodyPr/>
-                    <a:lstStyle/>
-                    <a:p>
-                      <a:pPr algn="l"/>
-                      <a:r>
-                        <a:rPr sz="1100" b="0">
-                          <a:solidFill>
-                            <a:srgbClr val="262626"/>
-                          </a:solidFill>
-                          <a:latin typeface="Calibri"/>
-                        </a:rPr>
-                        <a:t>Composite-unseen</a:t>
-                      </a:r>
-                    </a:p>
-                  </a:txBody>
-                  <a:tcPr>
-                    <a:noFill/>
-                  </a:tcPr>
-                </a:tc>
-                <a:tc>
-                  <a:txBody>
-                    <a:bodyPr/>
-                    <a:lstStyle/>
-                    <a:p>
-                      <a:pPr algn="l"/>
-                      <a:r>
-                        <a:rPr sz="1100" b="0">
-                          <a:solidFill>
-                            <a:srgbClr val="262626"/>
-                          </a:solidFill>
-                          <a:latin typeface="Calibri"/>
-                        </a:rPr>
-                        <a:t>~500</a:t>
-                      </a:r>
-                    </a:p>
-                  </a:txBody>
-                  <a:tcPr>
-                    <a:noFill/>
-                  </a:tcPr>
-                </a:tc>
-                <a:tc>
-                  <a:txBody>
-                    <a:bodyPr/>
-                    <a:lstStyle/>
-                    <a:p>
-                      <a:pPr algn="l"/>
-                      <a:r>
-                        <a:rPr sz="1100" b="0">
-                          <a:solidFill>
-                            <a:srgbClr val="262626"/>
-                          </a:solidFill>
-                          <a:latin typeface="Calibri"/>
-                        </a:rPr>
-                        <a:t>~8,000</a:t>
-                      </a:r>
-                    </a:p>
-                  </a:txBody>
-                  <a:tcPr>
-                    <a:noFill/>
-                  </a:tcPr>
-                </a:tc>
-              </a:tr>
-              <a:tr h="338328">
-                <a:tc>
-                  <a:txBody>
-                    <a:bodyPr/>
-                    <a:lstStyle/>
-                    <a:p>
-                      <a:pPr algn="l"/>
-                      <a:r>
-                        <a:rPr sz="1100" b="0">
-                          <a:solidFill>
                             <a:srgbClr val="1F4E79"/>
                           </a:solidFill>
                           <a:latin typeface="Calibri"/>
                         </a:rPr>
-                        <a:t>Total</a:t>
-                      </a:r>
-                    </a:p>
-                  </a:txBody>
-                  <a:tcPr>
-                    <a:solidFill>
-                      <a:srgbClr val="F2F2F2"/>
-                    </a:solidFill>
-                  </a:tcPr>
-                </a:tc>
-                <a:tc>
-                  <a:txBody>
-                    <a:bodyPr/>
-                    <a:lstStyle/>
-                    <a:p>
-                      <a:pPr algn="l"/>
-                      <a:r>
-                        <a:rPr sz="1100" b="0">
-                          <a:solidFill>
-                            <a:srgbClr val="262626"/>
-                          </a:solidFill>
-                          <a:latin typeface="Calibri"/>
-                        </a:rPr>
-                        <a:t>—</a:t>
-                      </a:r>
-                    </a:p>
-                  </a:txBody>
-                  <a:tcPr>
-                    <a:solidFill>
-                      <a:srgbClr val="F2F2F2"/>
-                    </a:solidFill>
-                  </a:tcPr>
-                </a:tc>
-                <a:tc>
-                  <a:txBody>
-                    <a:bodyPr/>
-                    <a:lstStyle/>
-                    <a:p>
-                      <a:pPr algn="l"/>
-                      <a:r>
-                        <a:rPr sz="1100" b="0">
-                          <a:solidFill>
-                            <a:srgbClr val="1F4E79"/>
-                          </a:solidFill>
-                          <a:latin typeface="Calibri"/>
-                        </a:rPr>
                         <a:t>50</a:t>
-                      </a:r>
-                    </a:p>
-                  </a:txBody>
-                  <a:tcPr>
-                    <a:solidFill>
-                      <a:srgbClr val="F2F2F2"/>
-                    </a:solidFill>
-                  </a:tcPr>
-                </a:tc>
-                <a:tc>
-                  <a:txBody>
-                    <a:bodyPr/>
-                    <a:lstStyle/>
-                    <a:p>
-                      <a:pPr algn="l"/>
-                      <a:r>
-                        <a:rPr sz="1100" b="0">
-                          <a:solidFill>
-                            <a:srgbClr val="262626"/>
-                          </a:solidFill>
-                          <a:latin typeface="Calibri"/>
-                        </a:rPr>
-                        <a:t>—</a:t>
                       </a:r>
                     </a:p>
                   </a:txBody>
@@ -23845,8 +23623,8 @@
         </p:nvSpPr>
         <p:spPr>
           <a:xfrm>
-            <a:off x="457200" y="5074920"/>
-            <a:ext cx="11247120" cy="685800"/>
+            <a:off x="457200" y="3502152"/>
+            <a:ext cx="11247120" cy="658368"/>
           </a:xfrm>
           <a:prstGeom prst="rect">
             <a:avLst/>
@@ -23890,8 +23668,8 @@
         </p:nvSpPr>
         <p:spPr>
           <a:xfrm>
-            <a:off x="594360" y="5120640"/>
-            <a:ext cx="10972800" cy="594360"/>
+            <a:off x="594360" y="3547872"/>
+            <a:ext cx="10972800" cy="566928"/>
           </a:xfrm>
           <a:prstGeom prst="rect">
             <a:avLst/>

</xml_diff>

<commit_message>
Revert slide 5c to stacked full-width table layout
</commit_message>
<xml_diff>
--- a/robocasa_slides.pptx
+++ b/robocasa_slides.pptx
@@ -22504,7 +22504,7 @@
         <p:spPr>
           <a:xfrm>
             <a:off x="457200" y="960120"/>
-            <a:ext cx="5577840" cy="292608"/>
+            <a:ext cx="11247120" cy="292608"/>
           </a:xfrm>
           <a:prstGeom prst="rect">
             <a:avLst/>
@@ -22540,7 +22540,7 @@
         </p:nvGraphicFramePr>
         <p:xfrm>
           <a:off x="457200" y="1307592"/>
-          <a:ext cx="5577840" cy="1965960"/>
+          <a:ext cx="11247120" cy="1417320"/>
         </p:xfrm>
         <a:graphic>
           <a:graphicData uri="http://schemas.openxmlformats.org/drawingml/2006/table">
@@ -22549,12 +22549,14 @@
                 <a:tableStyleId>{5C22544A-7EE6-4342-B048-85BDC9FD1C3A}</a:tableStyleId>
               </a:tblPr>
               <a:tblGrid>
-                <a:gridCol w="2331720"/>
+                <a:gridCol w="2286000"/>
                 <a:gridCol w="914400"/>
-                <a:gridCol w="1188720"/>
-                <a:gridCol w="1143000"/>
+                <a:gridCol w="914400"/>
+                <a:gridCol w="1371600"/>
+                <a:gridCol w="1554480"/>
+                <a:gridCol w="4206240"/>
               </a:tblGrid>
-              <a:tr h="327660">
+              <a:tr h="354330">
                 <a:tc>
                   <a:txBody>
                     <a:bodyPr/>
@@ -22591,7 +22593,7 @@
                           </a:solidFill>
                           <a:latin typeface="Calibri"/>
                         </a:rPr>
-                        <a:t>Tasks</a:t>
+                        <a:t>Split</a:t>
                       </a:r>
                     </a:p>
                   </a:txBody>
@@ -22614,7 +22616,7 @@
                           </a:solidFill>
                           <a:latin typeface="Calibri"/>
                         </a:rPr>
-                        <a:t>Episodes / Task</a:t>
+                        <a:t># Tasks</a:t>
                       </a:r>
                     </a:p>
                   </a:txBody>
@@ -22637,7 +22639,7 @@
                           </a:solidFill>
                           <a:latin typeface="Calibri"/>
                         </a:rPr>
-                        <a:t>Total Episodes</a:t>
+                        <a:t>Demos / Task</a:t>
                       </a:r>
                     </a:p>
                   </a:txBody>
@@ -22647,8 +22649,54 @@
                     </a:solidFill>
                   </a:tcPr>
                 </a:tc>
+                <a:tc>
+                  <a:txBody>
+                    <a:bodyPr/>
+                    <a:lstStyle/>
+                    <a:p>
+                      <a:pPr algn="l"/>
+                      <a:r>
+                        <a:rPr sz="1200" b="1">
+                          <a:solidFill>
+                            <a:srgbClr val="1F4E79"/>
+                          </a:solidFill>
+                          <a:latin typeface="Calibri"/>
+                        </a:rPr>
+                        <a:t>Total Demos</a:t>
+                      </a:r>
+                    </a:p>
+                  </a:txBody>
+                  <a:tcPr>
+                    <a:solidFill>
+                      <a:srgbClr val="D6E4F0"/>
+                    </a:solidFill>
+                  </a:tcPr>
+                </a:tc>
+                <a:tc>
+                  <a:txBody>
+                    <a:bodyPr/>
+                    <a:lstStyle/>
+                    <a:p>
+                      <a:pPr algn="l"/>
+                      <a:r>
+                        <a:rPr sz="1200" b="1">
+                          <a:solidFill>
+                            <a:srgbClr val="1F4E79"/>
+                          </a:solidFill>
+                          <a:latin typeface="Calibri"/>
+                        </a:rPr>
+                        <a:t>Total Hours</a:t>
+                      </a:r>
+                    </a:p>
+                  </a:txBody>
+                  <a:tcPr>
+                    <a:solidFill>
+                      <a:srgbClr val="D6E4F0"/>
+                    </a:solidFill>
+                  </a:tcPr>
+                </a:tc>
               </a:tr>
-              <a:tr h="327660">
+              <a:tr h="354330">
                 <a:tc>
                   <a:txBody>
                     <a:bodyPr/>
@@ -22662,7 +22710,7 @@
                           </a:solidFill>
                           <a:latin typeface="Calibri"/>
                         </a:rPr>
-                        <a:t>Human demos — atomic</a:t>
+                        <a:t>Human teleoperation</a:t>
                       </a:r>
                     </a:p>
                   </a:txBody>
@@ -22683,7 +22731,7 @@
                           </a:solidFill>
                           <a:latin typeface="Calibri"/>
                         </a:rPr>
-                        <a:t>65</a:t>
+                        <a:t>Pretrain</a:t>
                       </a:r>
                     </a:p>
                   </a:txBody>
@@ -22704,6 +22752,27 @@
                           </a:solidFill>
                           <a:latin typeface="Calibri"/>
                         </a:rPr>
+                        <a:t>300</a:t>
+                      </a:r>
+                    </a:p>
+                  </a:txBody>
+                  <a:tcPr>
+                    <a:noFill/>
+                  </a:tcPr>
+                </a:tc>
+                <a:tc>
+                  <a:txBody>
+                    <a:bodyPr/>
+                    <a:lstStyle/>
+                    <a:p>
+                      <a:pPr algn="l"/>
+                      <a:r>
+                        <a:rPr sz="1100" b="0">
+                          <a:solidFill>
+                            <a:srgbClr val="262626"/>
+                          </a:solidFill>
+                          <a:latin typeface="Calibri"/>
+                        </a:rPr>
                         <a:t>~100</a:t>
                       </a:r>
                     </a:p>
@@ -22725,7 +22794,7 @@
                           </a:solidFill>
                           <a:latin typeface="Calibri"/>
                         </a:rPr>
-                        <a:t>6,500</a:t>
+                        <a:t>~30,000</a:t>
                       </a:r>
                     </a:p>
                   </a:txBody>
@@ -22733,8 +22802,29 @@
                     <a:noFill/>
                   </a:tcPr>
                 </a:tc>
+                <a:tc>
+                  <a:txBody>
+                    <a:bodyPr/>
+                    <a:lstStyle/>
+                    <a:p>
+                      <a:pPr algn="l"/>
+                      <a:r>
+                        <a:rPr sz="1100" b="0">
+                          <a:solidFill>
+                            <a:srgbClr val="262626"/>
+                          </a:solidFill>
+                          <a:latin typeface="Calibri"/>
+                        </a:rPr>
+                        <a:t>482 hrs</a:t>
+                      </a:r>
+                    </a:p>
+                  </a:txBody>
+                  <a:tcPr>
+                    <a:noFill/>
+                  </a:tcPr>
+                </a:tc>
               </a:tr>
-              <a:tr h="327660">
+              <a:tr h="354330">
                 <a:tc>
                   <a:txBody>
                     <a:bodyPr/>
@@ -22748,7 +22838,7 @@
                           </a:solidFill>
                           <a:latin typeface="Calibri"/>
                         </a:rPr>
-                        <a:t>Human demos — composite</a:t>
+                        <a:t>MimicGen (synthetic)</a:t>
                       </a:r>
                     </a:p>
                   </a:txBody>
@@ -22771,7 +22861,7 @@
                           </a:solidFill>
                           <a:latin typeface="Calibri"/>
                         </a:rPr>
-                        <a:t>252</a:t>
+                        <a:t>Pretrain</a:t>
                       </a:r>
                     </a:p>
                   </a:txBody>
@@ -22794,7 +22884,7 @@
                           </a:solidFill>
                           <a:latin typeface="Calibri"/>
                         </a:rPr>
-                        <a:t>~100</a:t>
+                        <a:t>60</a:t>
                       </a:r>
                     </a:p>
                   </a:txBody>
@@ -22817,7 +22907,7 @@
                           </a:solidFill>
                           <a:latin typeface="Calibri"/>
                         </a:rPr>
-                        <a:t>25,200</a:t>
+                        <a:t>~10,000</a:t>
                       </a:r>
                     </a:p>
                   </a:txBody>
@@ -22827,50 +22917,6 @@
                     </a:solidFill>
                   </a:tcPr>
                 </a:tc>
-              </a:tr>
-              <a:tr h="327660">
-                <a:tc>
-                  <a:txBody>
-                    <a:bodyPr/>
-                    <a:lstStyle/>
-                    <a:p>
-                      <a:pPr algn="l"/>
-                      <a:r>
-                        <a:rPr sz="1100" b="0">
-                          <a:solidFill>
-                            <a:srgbClr val="595959"/>
-                          </a:solidFill>
-                          <a:latin typeface="Calibri"/>
-                        </a:rPr>
-                        <a:t>Human subtotal</a:t>
-                      </a:r>
-                    </a:p>
-                  </a:txBody>
-                  <a:tcPr>
-                    <a:noFill/>
-                  </a:tcPr>
-                </a:tc>
-                <a:tc>
-                  <a:txBody>
-                    <a:bodyPr/>
-                    <a:lstStyle/>
-                    <a:p>
-                      <a:pPr algn="l"/>
-                      <a:r>
-                        <a:rPr sz="1100" b="0">
-                          <a:solidFill>
-                            <a:srgbClr val="595959"/>
-                          </a:solidFill>
-                          <a:latin typeface="Calibri"/>
-                        </a:rPr>
-                        <a:t>317</a:t>
-                      </a:r>
-                    </a:p>
-                  </a:txBody>
-                  <a:tcPr>
-                    <a:noFill/>
-                  </a:tcPr>
-                </a:tc>
                 <a:tc>
                   <a:txBody>
                     <a:bodyPr/>
@@ -22884,51 +22930,7 @@
                           </a:solidFill>
                           <a:latin typeface="Calibri"/>
                         </a:rPr>
-                        <a:t>—</a:t>
-                      </a:r>
-                    </a:p>
-                  </a:txBody>
-                  <a:tcPr>
-                    <a:noFill/>
-                  </a:tcPr>
-                </a:tc>
-                <a:tc>
-                  <a:txBody>
-                    <a:bodyPr/>
-                    <a:lstStyle/>
-                    <a:p>
-                      <a:pPr algn="l"/>
-                      <a:r>
-                        <a:rPr sz="1100" b="0">
-                          <a:solidFill>
-                            <a:srgbClr val="595959"/>
-                          </a:solidFill>
-                          <a:latin typeface="Calibri"/>
-                        </a:rPr>
-                        <a:t>~31,700</a:t>
-                      </a:r>
-                    </a:p>
-                  </a:txBody>
-                  <a:tcPr>
-                    <a:noFill/>
-                  </a:tcPr>
-                </a:tc>
-              </a:tr>
-              <a:tr h="327660">
-                <a:tc>
-                  <a:txBody>
-                    <a:bodyPr/>
-                    <a:lstStyle/>
-                    <a:p>
-                      <a:pPr algn="l"/>
-                      <a:r>
-                        <a:rPr sz="1100" b="0">
-                          <a:solidFill>
-                            <a:srgbClr val="262626"/>
-                          </a:solidFill>
-                          <a:latin typeface="Calibri"/>
-                        </a:rPr>
-                        <a:t>MimicGen (synthetic)</a:t>
+                        <a:t>~600,000</a:t>
                       </a:r>
                     </a:p>
                   </a:txBody>
@@ -22951,7 +22953,7 @@
                           </a:solidFill>
                           <a:latin typeface="Calibri"/>
                         </a:rPr>
-                        <a:t>60 atomic</a:t>
+                        <a:t>1,615 hrs</a:t>
                       </a:r>
                     </a:p>
                   </a:txBody>
@@ -22961,6 +22963,29 @@
                     </a:solidFill>
                   </a:tcPr>
                 </a:tc>
+              </a:tr>
+              <a:tr h="354330">
+                <a:tc>
+                  <a:txBody>
+                    <a:bodyPr/>
+                    <a:lstStyle/>
+                    <a:p>
+                      <a:pPr algn="l"/>
+                      <a:r>
+                        <a:rPr sz="1100" b="0">
+                          <a:solidFill>
+                            <a:srgbClr val="1F4E79"/>
+                          </a:solidFill>
+                          <a:latin typeface="Calibri"/>
+                        </a:rPr>
+                        <a:t>Total</a:t>
+                      </a:r>
+                    </a:p>
+                  </a:txBody>
+                  <a:tcPr>
+                    <a:noFill/>
+                  </a:tcPr>
+                </a:tc>
                 <a:tc>
                   <a:txBody>
                     <a:bodyPr/>
@@ -22974,14 +22999,33 @@
                           </a:solidFill>
                           <a:latin typeface="Calibri"/>
                         </a:rPr>
-                        <a:t>~10,000</a:t>
-                      </a:r>
-                    </a:p>
-                  </a:txBody>
-                  <a:tcPr>
-                    <a:solidFill>
-                      <a:srgbClr val="F2F2F2"/>
-                    </a:solidFill>
+                        <a:t>—</a:t>
+                      </a:r>
+                    </a:p>
+                  </a:txBody>
+                  <a:tcPr>
+                    <a:noFill/>
+                  </a:tcPr>
+                </a:tc>
+                <a:tc>
+                  <a:txBody>
+                    <a:bodyPr/>
+                    <a:lstStyle/>
+                    <a:p>
+                      <a:pPr algn="l"/>
+                      <a:r>
+                        <a:rPr sz="1100" b="0">
+                          <a:solidFill>
+                            <a:srgbClr val="1F4E79"/>
+                          </a:solidFill>
+                          <a:latin typeface="Calibri"/>
+                        </a:rPr>
+                        <a:t>360</a:t>
+                      </a:r>
+                    </a:p>
+                  </a:txBody>
+                  <a:tcPr>
+                    <a:noFill/>
                   </a:tcPr>
                 </a:tc>
                 <a:tc>
@@ -22997,18 +23041,14 @@
                           </a:solidFill>
                           <a:latin typeface="Calibri"/>
                         </a:rPr>
-                        <a:t>~600,000</a:t>
-                      </a:r>
-                    </a:p>
-                  </a:txBody>
-                  <a:tcPr>
-                    <a:solidFill>
-                      <a:srgbClr val="F2F2F2"/>
-                    </a:solidFill>
-                  </a:tcPr>
-                </a:tc>
-              </a:tr>
-              <a:tr h="327660">
+                        <a:t>—</a:t>
+                      </a:r>
+                    </a:p>
+                  </a:txBody>
+                  <a:tcPr>
+                    <a:noFill/>
+                  </a:tcPr>
+                </a:tc>
                 <a:tc>
                   <a:txBody>
                     <a:bodyPr/>
@@ -23022,7 +23062,7 @@
                           </a:solidFill>
                           <a:latin typeface="Calibri"/>
                         </a:rPr>
-                        <a:t>Grand total</a:t>
+                        <a:t>~630,000</a:t>
                       </a:r>
                     </a:p>
                   </a:txBody>
@@ -23039,53 +23079,11 @@
                       <a:r>
                         <a:rPr sz="1100" b="0">
                           <a:solidFill>
-                            <a:srgbClr val="262626"/>
-                          </a:solidFill>
-                          <a:latin typeface="Calibri"/>
-                        </a:rPr>
-                        <a:t>—</a:t>
-                      </a:r>
-                    </a:p>
-                  </a:txBody>
-                  <a:tcPr>
-                    <a:noFill/>
-                  </a:tcPr>
-                </a:tc>
-                <a:tc>
-                  <a:txBody>
-                    <a:bodyPr/>
-                    <a:lstStyle/>
-                    <a:p>
-                      <a:pPr algn="l"/>
-                      <a:r>
-                        <a:rPr sz="1100" b="0">
-                          <a:solidFill>
-                            <a:srgbClr val="262626"/>
-                          </a:solidFill>
-                          <a:latin typeface="Calibri"/>
-                        </a:rPr>
-                        <a:t>—</a:t>
-                      </a:r>
-                    </a:p>
-                  </a:txBody>
-                  <a:tcPr>
-                    <a:noFill/>
-                  </a:tcPr>
-                </a:tc>
-                <a:tc>
-                  <a:txBody>
-                    <a:bodyPr/>
-                    <a:lstStyle/>
-                    <a:p>
-                      <a:pPr algn="l"/>
-                      <a:r>
-                        <a:rPr sz="1100" b="0">
-                          <a:solidFill>
                             <a:srgbClr val="1F4E79"/>
                           </a:solidFill>
                           <a:latin typeface="Calibri"/>
                         </a:rPr>
-                        <a:t>~631,700</a:t>
+                        <a:t>~2,097 hrs</a:t>
                       </a:r>
                     </a:p>
                   </a:txBody>
@@ -23106,8 +23104,8 @@
         </p:nvSpPr>
         <p:spPr>
           <a:xfrm>
-            <a:off x="6217920" y="960120"/>
-            <a:ext cx="5486400" cy="292608"/>
+            <a:off x="457200" y="2880360"/>
+            <a:ext cx="11247120" cy="292608"/>
           </a:xfrm>
           <a:prstGeom prst="rect">
             <a:avLst/>
@@ -23128,7 +23126,7 @@
                 </a:solidFill>
                 <a:latin typeface="Calibri"/>
               </a:rPr>
-              <a:t>Evaluation Data  (Target Split — RoboCasa365)</a:t>
+              <a:t>Evaluation Data  (Target Split — RoboCasa365, ICLR 2026)</a:t>
             </a:r>
           </a:p>
         </p:txBody>
@@ -23142,8 +23140,8 @@
           <p:nvPr/>
         </p:nvGraphicFramePr>
         <p:xfrm>
-          <a:off x="6217920" y="1307592"/>
-          <a:ext cx="5486400" cy="1691640"/>
+          <a:off x="457200" y="3227832"/>
+          <a:ext cx="11247120" cy="1691640"/>
         </p:xfrm>
         <a:graphic>
           <a:graphicData uri="http://schemas.openxmlformats.org/drawingml/2006/table">
@@ -23152,10 +23150,12 @@
                 <a:tableStyleId>{5C22544A-7EE6-4342-B048-85BDC9FD1C3A}</a:tableStyleId>
               </a:tblPr>
               <a:tblGrid>
-                <a:gridCol w="2103120"/>
-                <a:gridCol w="731520"/>
-                <a:gridCol w="1188720"/>
-                <a:gridCol w="1463040"/>
+                <a:gridCol w="2286000"/>
+                <a:gridCol w="914400"/>
+                <a:gridCol w="914400"/>
+                <a:gridCol w="1828800"/>
+                <a:gridCol w="1371600"/>
+                <a:gridCol w="3931920"/>
               </a:tblGrid>
               <a:tr h="338328">
                 <a:tc>
@@ -23171,7 +23171,7 @@
                           </a:solidFill>
                           <a:latin typeface="Calibri"/>
                         </a:rPr>
-                        <a:t>Subset</a:t>
+                        <a:t>Source</a:t>
                       </a:r>
                     </a:p>
                   </a:txBody>
@@ -23194,7 +23194,7 @@
                           </a:solidFill>
                           <a:latin typeface="Calibri"/>
                         </a:rPr>
-                        <a:t>Tasks</a:t>
+                        <a:t>Split</a:t>
                       </a:r>
                     </a:p>
                   </a:txBody>
@@ -23217,7 +23217,7 @@
                           </a:solidFill>
                           <a:latin typeface="Calibri"/>
                         </a:rPr>
-                        <a:t>Demos / Task</a:t>
+                        <a:t># Tasks</a:t>
                       </a:r>
                     </a:p>
                   </a:txBody>
@@ -23240,7 +23240,7 @@
                           </a:solidFill>
                           <a:latin typeface="Calibri"/>
                         </a:rPr>
-                        <a:t>Total Demos</a:t>
+                        <a:t>Subset</a:t>
                       </a:r>
                     </a:p>
                   </a:txBody>
@@ -23250,6 +23250,52 @@
                     </a:solidFill>
                   </a:tcPr>
                 </a:tc>
+                <a:tc>
+                  <a:txBody>
+                    <a:bodyPr/>
+                    <a:lstStyle/>
+                    <a:p>
+                      <a:pPr algn="l"/>
+                      <a:r>
+                        <a:rPr sz="1200" b="1">
+                          <a:solidFill>
+                            <a:srgbClr val="1F4E79"/>
+                          </a:solidFill>
+                          <a:latin typeface="Calibri"/>
+                        </a:rPr>
+                        <a:t>Demos / Task</a:t>
+                      </a:r>
+                    </a:p>
+                  </a:txBody>
+                  <a:tcPr>
+                    <a:solidFill>
+                      <a:srgbClr val="D6E4F0"/>
+                    </a:solidFill>
+                  </a:tcPr>
+                </a:tc>
+                <a:tc>
+                  <a:txBody>
+                    <a:bodyPr/>
+                    <a:lstStyle/>
+                    <a:p>
+                      <a:pPr algn="l"/>
+                      <a:r>
+                        <a:rPr sz="1200" b="1">
+                          <a:solidFill>
+                            <a:srgbClr val="1F4E79"/>
+                          </a:solidFill>
+                          <a:latin typeface="Calibri"/>
+                        </a:rPr>
+                        <a:t>Total Demos</a:t>
+                      </a:r>
+                    </a:p>
+                  </a:txBody>
+                  <a:tcPr>
+                    <a:solidFill>
+                      <a:srgbClr val="D6E4F0"/>
+                    </a:solidFill>
+                  </a:tcPr>
+                </a:tc>
               </a:tr>
               <a:tr h="338328">
                 <a:tc>
@@ -23265,28 +23311,70 @@
                           </a:solidFill>
                           <a:latin typeface="Calibri"/>
                         </a:rPr>
+                        <a:t>Human teleoperation</a:t>
+                      </a:r>
+                    </a:p>
+                  </a:txBody>
+                  <a:tcPr>
+                    <a:noFill/>
+                  </a:tcPr>
+                </a:tc>
+                <a:tc>
+                  <a:txBody>
+                    <a:bodyPr/>
+                    <a:lstStyle/>
+                    <a:p>
+                      <a:pPr algn="l"/>
+                      <a:r>
+                        <a:rPr sz="1100" b="0">
+                          <a:solidFill>
+                            <a:srgbClr val="262626"/>
+                          </a:solidFill>
+                          <a:latin typeface="Calibri"/>
+                        </a:rPr>
+                        <a:t>Target</a:t>
+                      </a:r>
+                    </a:p>
+                  </a:txBody>
+                  <a:tcPr>
+                    <a:noFill/>
+                  </a:tcPr>
+                </a:tc>
+                <a:tc>
+                  <a:txBody>
+                    <a:bodyPr/>
+                    <a:lstStyle/>
+                    <a:p>
+                      <a:pPr algn="l"/>
+                      <a:r>
+                        <a:rPr sz="1100" b="0">
+                          <a:solidFill>
+                            <a:srgbClr val="262626"/>
+                          </a:solidFill>
+                          <a:latin typeface="Calibri"/>
+                        </a:rPr>
+                        <a:t>18</a:t>
+                      </a:r>
+                    </a:p>
+                  </a:txBody>
+                  <a:tcPr>
+                    <a:noFill/>
+                  </a:tcPr>
+                </a:tc>
+                <a:tc>
+                  <a:txBody>
+                    <a:bodyPr/>
+                    <a:lstStyle/>
+                    <a:p>
+                      <a:pPr algn="l"/>
+                      <a:r>
+                        <a:rPr sz="1100" b="0">
+                          <a:solidFill>
+                            <a:srgbClr val="262626"/>
+                          </a:solidFill>
+                          <a:latin typeface="Calibri"/>
+                        </a:rPr>
                         <a:t>Atomic-seen</a:t>
-                      </a:r>
-                    </a:p>
-                  </a:txBody>
-                  <a:tcPr>
-                    <a:noFill/>
-                  </a:tcPr>
-                </a:tc>
-                <a:tc>
-                  <a:txBody>
-                    <a:bodyPr/>
-                    <a:lstStyle/>
-                    <a:p>
-                      <a:pPr algn="l"/>
-                      <a:r>
-                        <a:rPr sz="1100" b="0">
-                          <a:solidFill>
-                            <a:srgbClr val="262626"/>
-                          </a:solidFill>
-                          <a:latin typeface="Calibri"/>
-                        </a:rPr>
-                        <a:t>18</a:t>
                       </a:r>
                     </a:p>
                   </a:txBody>
@@ -23351,7 +23439,7 @@
                           </a:solidFill>
                           <a:latin typeface="Calibri"/>
                         </a:rPr>
-                        <a:t>Composite-seen</a:t>
+                        <a:t>Human teleoperation</a:t>
                       </a:r>
                     </a:p>
                   </a:txBody>
@@ -23374,7 +23462,7 @@
                           </a:solidFill>
                           <a:latin typeface="Calibri"/>
                         </a:rPr>
-                        <a:t>16</a:t>
+                        <a:t>Target</a:t>
                       </a:r>
                     </a:p>
                   </a:txBody>
@@ -23397,7 +23485,7 @@
                           </a:solidFill>
                           <a:latin typeface="Calibri"/>
                         </a:rPr>
-                        <a:t>~500</a:t>
+                        <a:t>16</a:t>
                       </a:r>
                     </a:p>
                   </a:txBody>
@@ -23420,7 +23508,7 @@
                           </a:solidFill>
                           <a:latin typeface="Calibri"/>
                         </a:rPr>
-                        <a:t>~8,000</a:t>
+                        <a:t>Composite-seen</a:t>
                       </a:r>
                     </a:p>
                   </a:txBody>
@@ -23430,8 +23518,6 @@
                     </a:solidFill>
                   </a:tcPr>
                 </a:tc>
-              </a:tr>
-              <a:tr h="338328">
                 <a:tc>
                   <a:txBody>
                     <a:bodyPr/>
@@ -23445,93 +23531,7 @@
                           </a:solidFill>
                           <a:latin typeface="Calibri"/>
                         </a:rPr>
-                        <a:t>Composite-unseen</a:t>
-                      </a:r>
-                    </a:p>
-                  </a:txBody>
-                  <a:tcPr>
-                    <a:noFill/>
-                  </a:tcPr>
-                </a:tc>
-                <a:tc>
-                  <a:txBody>
-                    <a:bodyPr/>
-                    <a:lstStyle/>
-                    <a:p>
-                      <a:pPr algn="l"/>
-                      <a:r>
-                        <a:rPr sz="1100" b="0">
-                          <a:solidFill>
-                            <a:srgbClr val="262626"/>
-                          </a:solidFill>
-                          <a:latin typeface="Calibri"/>
-                        </a:rPr>
-                        <a:t>16</a:t>
-                      </a:r>
-                    </a:p>
-                  </a:txBody>
-                  <a:tcPr>
-                    <a:noFill/>
-                  </a:tcPr>
-                </a:tc>
-                <a:tc>
-                  <a:txBody>
-                    <a:bodyPr/>
-                    <a:lstStyle/>
-                    <a:p>
-                      <a:pPr algn="l"/>
-                      <a:r>
-                        <a:rPr sz="1100" b="0">
-                          <a:solidFill>
-                            <a:srgbClr val="262626"/>
-                          </a:solidFill>
-                          <a:latin typeface="Calibri"/>
-                        </a:rPr>
                         <a:t>~500</a:t>
-                      </a:r>
-                    </a:p>
-                  </a:txBody>
-                  <a:tcPr>
-                    <a:noFill/>
-                  </a:tcPr>
-                </a:tc>
-                <a:tc>
-                  <a:txBody>
-                    <a:bodyPr/>
-                    <a:lstStyle/>
-                    <a:p>
-                      <a:pPr algn="l"/>
-                      <a:r>
-                        <a:rPr sz="1100" b="0">
-                          <a:solidFill>
-                            <a:srgbClr val="262626"/>
-                          </a:solidFill>
-                          <a:latin typeface="Calibri"/>
-                        </a:rPr>
-                        <a:t>~8,000</a:t>
-                      </a:r>
-                    </a:p>
-                  </a:txBody>
-                  <a:tcPr>
-                    <a:noFill/>
-                  </a:tcPr>
-                </a:tc>
-              </a:tr>
-              <a:tr h="338328">
-                <a:tc>
-                  <a:txBody>
-                    <a:bodyPr/>
-                    <a:lstStyle/>
-                    <a:p>
-                      <a:pPr algn="l"/>
-                      <a:r>
-                        <a:rPr sz="1100" b="0">
-                          <a:solidFill>
-                            <a:srgbClr val="1F4E79"/>
-                          </a:solidFill>
-                          <a:latin typeface="Calibri"/>
-                        </a:rPr>
-                        <a:t>Total</a:t>
                       </a:r>
                     </a:p>
                   </a:txBody>
@@ -23550,11 +23550,233 @@
                       <a:r>
                         <a:rPr sz="1100" b="0">
                           <a:solidFill>
+                            <a:srgbClr val="262626"/>
+                          </a:solidFill>
+                          <a:latin typeface="Calibri"/>
+                        </a:rPr>
+                        <a:t>~8,000</a:t>
+                      </a:r>
+                    </a:p>
+                  </a:txBody>
+                  <a:tcPr>
+                    <a:solidFill>
+                      <a:srgbClr val="F2F2F2"/>
+                    </a:solidFill>
+                  </a:tcPr>
+                </a:tc>
+              </a:tr>
+              <a:tr h="338328">
+                <a:tc>
+                  <a:txBody>
+                    <a:bodyPr/>
+                    <a:lstStyle/>
+                    <a:p>
+                      <a:pPr algn="l"/>
+                      <a:r>
+                        <a:rPr sz="1100" b="0">
+                          <a:solidFill>
+                            <a:srgbClr val="262626"/>
+                          </a:solidFill>
+                          <a:latin typeface="Calibri"/>
+                        </a:rPr>
+                        <a:t>Human teleoperation</a:t>
+                      </a:r>
+                    </a:p>
+                  </a:txBody>
+                  <a:tcPr>
+                    <a:noFill/>
+                  </a:tcPr>
+                </a:tc>
+                <a:tc>
+                  <a:txBody>
+                    <a:bodyPr/>
+                    <a:lstStyle/>
+                    <a:p>
+                      <a:pPr algn="l"/>
+                      <a:r>
+                        <a:rPr sz="1100" b="0">
+                          <a:solidFill>
+                            <a:srgbClr val="262626"/>
+                          </a:solidFill>
+                          <a:latin typeface="Calibri"/>
+                        </a:rPr>
+                        <a:t>Target</a:t>
+                      </a:r>
+                    </a:p>
+                  </a:txBody>
+                  <a:tcPr>
+                    <a:noFill/>
+                  </a:tcPr>
+                </a:tc>
+                <a:tc>
+                  <a:txBody>
+                    <a:bodyPr/>
+                    <a:lstStyle/>
+                    <a:p>
+                      <a:pPr algn="l"/>
+                      <a:r>
+                        <a:rPr sz="1100" b="0">
+                          <a:solidFill>
+                            <a:srgbClr val="262626"/>
+                          </a:solidFill>
+                          <a:latin typeface="Calibri"/>
+                        </a:rPr>
+                        <a:t>16</a:t>
+                      </a:r>
+                    </a:p>
+                  </a:txBody>
+                  <a:tcPr>
+                    <a:noFill/>
+                  </a:tcPr>
+                </a:tc>
+                <a:tc>
+                  <a:txBody>
+                    <a:bodyPr/>
+                    <a:lstStyle/>
+                    <a:p>
+                      <a:pPr algn="l"/>
+                      <a:r>
+                        <a:rPr sz="1100" b="0">
+                          <a:solidFill>
+                            <a:srgbClr val="262626"/>
+                          </a:solidFill>
+                          <a:latin typeface="Calibri"/>
+                        </a:rPr>
+                        <a:t>Composite-unseen</a:t>
+                      </a:r>
+                    </a:p>
+                  </a:txBody>
+                  <a:tcPr>
+                    <a:noFill/>
+                  </a:tcPr>
+                </a:tc>
+                <a:tc>
+                  <a:txBody>
+                    <a:bodyPr/>
+                    <a:lstStyle/>
+                    <a:p>
+                      <a:pPr algn="l"/>
+                      <a:r>
+                        <a:rPr sz="1100" b="0">
+                          <a:solidFill>
+                            <a:srgbClr val="262626"/>
+                          </a:solidFill>
+                          <a:latin typeface="Calibri"/>
+                        </a:rPr>
+                        <a:t>~500</a:t>
+                      </a:r>
+                    </a:p>
+                  </a:txBody>
+                  <a:tcPr>
+                    <a:noFill/>
+                  </a:tcPr>
+                </a:tc>
+                <a:tc>
+                  <a:txBody>
+                    <a:bodyPr/>
+                    <a:lstStyle/>
+                    <a:p>
+                      <a:pPr algn="l"/>
+                      <a:r>
+                        <a:rPr sz="1100" b="0">
+                          <a:solidFill>
+                            <a:srgbClr val="262626"/>
+                          </a:solidFill>
+                          <a:latin typeface="Calibri"/>
+                        </a:rPr>
+                        <a:t>~8,000</a:t>
+                      </a:r>
+                    </a:p>
+                  </a:txBody>
+                  <a:tcPr>
+                    <a:noFill/>
+                  </a:tcPr>
+                </a:tc>
+              </a:tr>
+              <a:tr h="338328">
+                <a:tc>
+                  <a:txBody>
+                    <a:bodyPr/>
+                    <a:lstStyle/>
+                    <a:p>
+                      <a:pPr algn="l"/>
+                      <a:r>
+                        <a:rPr sz="1100" b="0">
+                          <a:solidFill>
                             <a:srgbClr val="1F4E79"/>
                           </a:solidFill>
                           <a:latin typeface="Calibri"/>
                         </a:rPr>
+                        <a:t>Total</a:t>
+                      </a:r>
+                    </a:p>
+                  </a:txBody>
+                  <a:tcPr>
+                    <a:solidFill>
+                      <a:srgbClr val="F2F2F2"/>
+                    </a:solidFill>
+                  </a:tcPr>
+                </a:tc>
+                <a:tc>
+                  <a:txBody>
+                    <a:bodyPr/>
+                    <a:lstStyle/>
+                    <a:p>
+                      <a:pPr algn="l"/>
+                      <a:r>
+                        <a:rPr sz="1100" b="0">
+                          <a:solidFill>
+                            <a:srgbClr val="262626"/>
+                          </a:solidFill>
+                          <a:latin typeface="Calibri"/>
+                        </a:rPr>
+                        <a:t>—</a:t>
+                      </a:r>
+                    </a:p>
+                  </a:txBody>
+                  <a:tcPr>
+                    <a:solidFill>
+                      <a:srgbClr val="F2F2F2"/>
+                    </a:solidFill>
+                  </a:tcPr>
+                </a:tc>
+                <a:tc>
+                  <a:txBody>
+                    <a:bodyPr/>
+                    <a:lstStyle/>
+                    <a:p>
+                      <a:pPr algn="l"/>
+                      <a:r>
+                        <a:rPr sz="1100" b="0">
+                          <a:solidFill>
+                            <a:srgbClr val="1F4E79"/>
+                          </a:solidFill>
+                          <a:latin typeface="Calibri"/>
+                        </a:rPr>
                         <a:t>50</a:t>
+                      </a:r>
+                    </a:p>
+                  </a:txBody>
+                  <a:tcPr>
+                    <a:solidFill>
+                      <a:srgbClr val="F2F2F2"/>
+                    </a:solidFill>
+                  </a:tcPr>
+                </a:tc>
+                <a:tc>
+                  <a:txBody>
+                    <a:bodyPr/>
+                    <a:lstStyle/>
+                    <a:p>
+                      <a:pPr algn="l"/>
+                      <a:r>
+                        <a:rPr sz="1100" b="0">
+                          <a:solidFill>
+                            <a:srgbClr val="262626"/>
+                          </a:solidFill>
+                          <a:latin typeface="Calibri"/>
+                        </a:rPr>
+                        <a:t>—</a:t>
                       </a:r>
                     </a:p>
                   </a:txBody>
@@ -23623,8 +23845,8 @@
         </p:nvSpPr>
         <p:spPr>
           <a:xfrm>
-            <a:off x="457200" y="3502152"/>
-            <a:ext cx="11247120" cy="658368"/>
+            <a:off x="457200" y="5074920"/>
+            <a:ext cx="11247120" cy="685800"/>
           </a:xfrm>
           <a:prstGeom prst="rect">
             <a:avLst/>
@@ -23668,8 +23890,8 @@
         </p:nvSpPr>
         <p:spPr>
           <a:xfrm>
-            <a:off x="594360" y="3547872"/>
-            <a:ext cx="10972800" cy="566928"/>
+            <a:off x="594360" y="5120640"/>
+            <a:ext cx="10972800" cy="594360"/>
           </a:xfrm>
           <a:prstGeom prst="rect">
             <a:avLst/>

</xml_diff>